<commit_message>
MAMS-33 updated second order for LOAD and Power block part 1
</commit_message>
<xml_diff>
--- a/docs/meetings/Chart.pptx
+++ b/docs/meetings/Chart.pptx
@@ -6,6 +6,7 @@
   </p:sldMasterIdLst>
   <p:sldIdLst>
     <p:sldId id="256" r:id="rId2"/>
+    <p:sldId id="257" r:id="rId3"/>
   </p:sldIdLst>
   <p:sldSz cx="12192000" cy="6858000"/>
   <p:notesSz cx="6858000" cy="9144000"/>
@@ -496,7 +497,7 @@
           <a:p>
             <a:fld id="{2FD2B9CA-B971-4B45-8D3D-FECD6A0DEDEA}" type="datetimeFigureOut">
               <a:rPr lang="en-US" smtClean="0"/>
-              <a:t>3/1/2026</a:t>
+              <a:t>4/7/2026</a:t>
             </a:fld>
             <a:endParaRPr lang="en-US"/>
           </a:p>
@@ -694,7 +695,7 @@
           <a:p>
             <a:fld id="{2FD2B9CA-B971-4B45-8D3D-FECD6A0DEDEA}" type="datetimeFigureOut">
               <a:rPr lang="en-US" smtClean="0"/>
-              <a:t>3/1/2026</a:t>
+              <a:t>4/7/2026</a:t>
             </a:fld>
             <a:endParaRPr lang="en-US"/>
           </a:p>
@@ -902,7 +903,7 @@
           <a:p>
             <a:fld id="{2FD2B9CA-B971-4B45-8D3D-FECD6A0DEDEA}" type="datetimeFigureOut">
               <a:rPr lang="en-US" smtClean="0"/>
-              <a:t>3/1/2026</a:t>
+              <a:t>4/7/2026</a:t>
             </a:fld>
             <a:endParaRPr lang="en-US"/>
           </a:p>
@@ -1100,7 +1101,7 @@
           <a:p>
             <a:fld id="{2FD2B9CA-B971-4B45-8D3D-FECD6A0DEDEA}" type="datetimeFigureOut">
               <a:rPr lang="en-US" smtClean="0"/>
-              <a:t>3/1/2026</a:t>
+              <a:t>4/7/2026</a:t>
             </a:fld>
             <a:endParaRPr lang="en-US"/>
           </a:p>
@@ -1375,7 +1376,7 @@
           <a:p>
             <a:fld id="{2FD2B9CA-B971-4B45-8D3D-FECD6A0DEDEA}" type="datetimeFigureOut">
               <a:rPr lang="en-US" smtClean="0"/>
-              <a:t>3/1/2026</a:t>
+              <a:t>4/7/2026</a:t>
             </a:fld>
             <a:endParaRPr lang="en-US"/>
           </a:p>
@@ -1640,7 +1641,7 @@
           <a:p>
             <a:fld id="{2FD2B9CA-B971-4B45-8D3D-FECD6A0DEDEA}" type="datetimeFigureOut">
               <a:rPr lang="en-US" smtClean="0"/>
-              <a:t>3/1/2026</a:t>
+              <a:t>4/7/2026</a:t>
             </a:fld>
             <a:endParaRPr lang="en-US"/>
           </a:p>
@@ -2052,7 +2053,7 @@
           <a:p>
             <a:fld id="{2FD2B9CA-B971-4B45-8D3D-FECD6A0DEDEA}" type="datetimeFigureOut">
               <a:rPr lang="en-US" smtClean="0"/>
-              <a:t>3/1/2026</a:t>
+              <a:t>4/7/2026</a:t>
             </a:fld>
             <a:endParaRPr lang="en-US"/>
           </a:p>
@@ -2193,7 +2194,7 @@
           <a:p>
             <a:fld id="{2FD2B9CA-B971-4B45-8D3D-FECD6A0DEDEA}" type="datetimeFigureOut">
               <a:rPr lang="en-US" smtClean="0"/>
-              <a:t>3/1/2026</a:t>
+              <a:t>4/7/2026</a:t>
             </a:fld>
             <a:endParaRPr lang="en-US"/>
           </a:p>
@@ -2306,7 +2307,7 @@
           <a:p>
             <a:fld id="{2FD2B9CA-B971-4B45-8D3D-FECD6A0DEDEA}" type="datetimeFigureOut">
               <a:rPr lang="en-US" smtClean="0"/>
-              <a:t>3/1/2026</a:t>
+              <a:t>4/7/2026</a:t>
             </a:fld>
             <a:endParaRPr lang="en-US"/>
           </a:p>
@@ -2617,7 +2618,7 @@
           <a:p>
             <a:fld id="{2FD2B9CA-B971-4B45-8D3D-FECD6A0DEDEA}" type="datetimeFigureOut">
               <a:rPr lang="en-US" smtClean="0"/>
-              <a:t>3/1/2026</a:t>
+              <a:t>4/7/2026</a:t>
             </a:fld>
             <a:endParaRPr lang="en-US"/>
           </a:p>
@@ -2905,7 +2906,7 @@
           <a:p>
             <a:fld id="{2FD2B9CA-B971-4B45-8D3D-FECD6A0DEDEA}" type="datetimeFigureOut">
               <a:rPr lang="en-US" smtClean="0"/>
-              <a:t>3/1/2026</a:t>
+              <a:t>4/7/2026</a:t>
             </a:fld>
             <a:endParaRPr lang="en-US"/>
           </a:p>
@@ -3146,7 +3147,7 @@
           <a:p>
             <a:fld id="{2FD2B9CA-B971-4B45-8D3D-FECD6A0DEDEA}" type="datetimeFigureOut">
               <a:rPr lang="en-US" smtClean="0"/>
-              <a:t>3/1/2026</a:t>
+              <a:t>4/7/2026</a:t>
             </a:fld>
             <a:endParaRPr lang="en-US"/>
           </a:p>
@@ -6560,6 +6561,968 @@
 </p:sld>
 </file>
 
+<file path=ppt/slides/slide2.xml><?xml version="1.0" encoding="utf-8"?>
+<p:sld xmlns:a="http://schemas.openxmlformats.org/drawingml/2006/main" xmlns:r="http://schemas.openxmlformats.org/officeDocument/2006/relationships" xmlns:p="http://schemas.openxmlformats.org/presentationml/2006/main">
+  <p:cSld>
+    <p:spTree>
+      <p:nvGrpSpPr>
+        <p:cNvPr id="1" name=""/>
+        <p:cNvGrpSpPr/>
+        <p:nvPr/>
+      </p:nvGrpSpPr>
+      <p:grpSpPr>
+        <a:xfrm>
+          <a:off x="0" y="0"/>
+          <a:ext cx="0" cy="0"/>
+          <a:chOff x="0" y="0"/>
+          <a:chExt cx="0" cy="0"/>
+        </a:xfrm>
+      </p:grpSpPr>
+      <p:sp>
+        <p:nvSpPr>
+          <p:cNvPr id="2" name="Title 1">
+            <a:extLst>
+              <a:ext uri="{FF2B5EF4-FFF2-40B4-BE49-F238E27FC236}">
+                <a16:creationId xmlns:a16="http://schemas.microsoft.com/office/drawing/2014/main" id="{8B1C7229-4469-7BA6-FE7F-CA881DF5C528}"/>
+              </a:ext>
+            </a:extLst>
+          </p:cNvPr>
+          <p:cNvSpPr>
+            <a:spLocks noGrp="1"/>
+          </p:cNvSpPr>
+          <p:nvPr>
+            <p:ph type="title"/>
+          </p:nvPr>
+        </p:nvSpPr>
+        <p:spPr/>
+        <p:txBody>
+          <a:bodyPr/>
+          <a:lstStyle/>
+          <a:p>
+            <a:r>
+              <a:rPr lang="vi-VN" dirty="0">
+                <a:latin typeface="Aptos" panose="020B0004020202020204" pitchFamily="34" charset="0"/>
+              </a:rPr>
+              <a:t>Power block</a:t>
+            </a:r>
+            <a:endParaRPr lang="en-US" dirty="0">
+              <a:latin typeface="Aptos" panose="020B0004020202020204" pitchFamily="34" charset="0"/>
+            </a:endParaRPr>
+          </a:p>
+        </p:txBody>
+      </p:sp>
+      <p:sp>
+        <p:nvSpPr>
+          <p:cNvPr id="4" name="Rectangle 3">
+            <a:extLst>
+              <a:ext uri="{FF2B5EF4-FFF2-40B4-BE49-F238E27FC236}">
+                <a16:creationId xmlns:a16="http://schemas.microsoft.com/office/drawing/2014/main" id="{661DA5A0-F6F3-814A-18B8-EAA7C7E3D22C}"/>
+              </a:ext>
+            </a:extLst>
+          </p:cNvPr>
+          <p:cNvSpPr/>
+          <p:nvPr/>
+        </p:nvSpPr>
+        <p:spPr>
+          <a:xfrm>
+            <a:off x="838200" y="2241550"/>
+            <a:ext cx="901700" cy="654050"/>
+          </a:xfrm>
+          <a:prstGeom prst="rect">
+            <a:avLst/>
+          </a:prstGeom>
+          <a:noFill/>
+        </p:spPr>
+        <p:style>
+          <a:lnRef idx="2">
+            <a:schemeClr val="accent1">
+              <a:shade val="15000"/>
+            </a:schemeClr>
+          </a:lnRef>
+          <a:fillRef idx="1">
+            <a:schemeClr val="accent1"/>
+          </a:fillRef>
+          <a:effectRef idx="0">
+            <a:schemeClr val="accent1"/>
+          </a:effectRef>
+          <a:fontRef idx="minor">
+            <a:schemeClr val="lt1"/>
+          </a:fontRef>
+        </p:style>
+        <p:txBody>
+          <a:bodyPr rtlCol="0" anchor="ctr"/>
+          <a:lstStyle/>
+          <a:p>
+            <a:pPr algn="ctr"/>
+            <a:r>
+              <a:rPr lang="vi-VN" dirty="0">
+                <a:solidFill>
+                  <a:schemeClr val="tx1"/>
+                </a:solidFill>
+              </a:rPr>
+              <a:t>12V input</a:t>
+            </a:r>
+          </a:p>
+        </p:txBody>
+      </p:sp>
+      <p:sp>
+        <p:nvSpPr>
+          <p:cNvPr id="5" name="Rectangle 4">
+            <a:extLst>
+              <a:ext uri="{FF2B5EF4-FFF2-40B4-BE49-F238E27FC236}">
+                <a16:creationId xmlns:a16="http://schemas.microsoft.com/office/drawing/2014/main" id="{B917C31E-3F3F-55F0-1F86-82E175C6377D}"/>
+              </a:ext>
+            </a:extLst>
+          </p:cNvPr>
+          <p:cNvSpPr/>
+          <p:nvPr/>
+        </p:nvSpPr>
+        <p:spPr>
+          <a:xfrm>
+            <a:off x="3028950" y="2241550"/>
+            <a:ext cx="977900" cy="654050"/>
+          </a:xfrm>
+          <a:prstGeom prst="rect">
+            <a:avLst/>
+          </a:prstGeom>
+          <a:noFill/>
+        </p:spPr>
+        <p:style>
+          <a:lnRef idx="2">
+            <a:schemeClr val="accent1">
+              <a:shade val="15000"/>
+            </a:schemeClr>
+          </a:lnRef>
+          <a:fillRef idx="1">
+            <a:schemeClr val="accent1"/>
+          </a:fillRef>
+          <a:effectRef idx="0">
+            <a:schemeClr val="accent1"/>
+          </a:effectRef>
+          <a:fontRef idx="minor">
+            <a:schemeClr val="lt1"/>
+          </a:fontRef>
+        </p:style>
+        <p:txBody>
+          <a:bodyPr rtlCol="0" anchor="ctr"/>
+          <a:lstStyle/>
+          <a:p>
+            <a:pPr algn="ctr"/>
+            <a:r>
+              <a:rPr lang="vi-VN" sz="1400" dirty="0">
+                <a:solidFill>
+                  <a:schemeClr val="tx1"/>
+                </a:solidFill>
+              </a:rPr>
+              <a:t>+5V_Pre</a:t>
+            </a:r>
+          </a:p>
+        </p:txBody>
+      </p:sp>
+      <p:cxnSp>
+        <p:nvCxnSpPr>
+          <p:cNvPr id="6" name="Straight Arrow Connector 5">
+            <a:extLst>
+              <a:ext uri="{FF2B5EF4-FFF2-40B4-BE49-F238E27FC236}">
+                <a16:creationId xmlns:a16="http://schemas.microsoft.com/office/drawing/2014/main" id="{50C84973-1939-A859-DF2A-7DB624B50ECD}"/>
+              </a:ext>
+            </a:extLst>
+          </p:cNvPr>
+          <p:cNvCxnSpPr>
+            <a:stCxn id="4" idx="3"/>
+            <a:endCxn id="5" idx="1"/>
+          </p:cNvCxnSpPr>
+          <p:nvPr/>
+        </p:nvCxnSpPr>
+        <p:spPr>
+          <a:xfrm>
+            <a:off x="1739900" y="2568575"/>
+            <a:ext cx="1289050" cy="0"/>
+          </a:xfrm>
+          <a:prstGeom prst="straightConnector1">
+            <a:avLst/>
+          </a:prstGeom>
+          <a:ln>
+            <a:tailEnd type="triangle"/>
+          </a:ln>
+        </p:spPr>
+        <p:style>
+          <a:lnRef idx="2">
+            <a:schemeClr val="accent1"/>
+          </a:lnRef>
+          <a:fillRef idx="0">
+            <a:schemeClr val="accent1"/>
+          </a:fillRef>
+          <a:effectRef idx="1">
+            <a:schemeClr val="accent1"/>
+          </a:effectRef>
+          <a:fontRef idx="minor">
+            <a:schemeClr val="tx1"/>
+          </a:fontRef>
+        </p:style>
+      </p:cxnSp>
+      <p:sp>
+        <p:nvSpPr>
+          <p:cNvPr id="7" name="TextBox 6">
+            <a:extLst>
+              <a:ext uri="{FF2B5EF4-FFF2-40B4-BE49-F238E27FC236}">
+                <a16:creationId xmlns:a16="http://schemas.microsoft.com/office/drawing/2014/main" id="{81A6CF2D-87E3-C9F6-12B3-89EAE074EEBA}"/>
+              </a:ext>
+            </a:extLst>
+          </p:cNvPr>
+          <p:cNvSpPr txBox="1"/>
+          <p:nvPr/>
+        </p:nvSpPr>
+        <p:spPr>
+          <a:xfrm>
+            <a:off x="1835150" y="2340059"/>
+            <a:ext cx="1289050" cy="276999"/>
+          </a:xfrm>
+          <a:prstGeom prst="rect">
+            <a:avLst/>
+          </a:prstGeom>
+          <a:noFill/>
+        </p:spPr>
+        <p:txBody>
+          <a:bodyPr wrap="square" rtlCol="0">
+            <a:spAutoFit/>
+          </a:bodyPr>
+          <a:lstStyle/>
+          <a:p>
+            <a:r>
+              <a:rPr lang="en-US" sz="1200" dirty="0">
+                <a:solidFill>
+                  <a:srgbClr val="FF0000"/>
+                </a:solidFill>
+              </a:rPr>
+              <a:t>ADP2303-5.0</a:t>
+            </a:r>
+          </a:p>
+        </p:txBody>
+      </p:sp>
+      <p:sp>
+        <p:nvSpPr>
+          <p:cNvPr id="8" name="Rectangle 7">
+            <a:extLst>
+              <a:ext uri="{FF2B5EF4-FFF2-40B4-BE49-F238E27FC236}">
+                <a16:creationId xmlns:a16="http://schemas.microsoft.com/office/drawing/2014/main" id="{CEE34824-264A-AD92-708E-D40DC3A65104}"/>
+              </a:ext>
+            </a:extLst>
+          </p:cNvPr>
+          <p:cNvSpPr/>
+          <p:nvPr/>
+        </p:nvSpPr>
+        <p:spPr>
+          <a:xfrm>
+            <a:off x="3028951" y="5838825"/>
+            <a:ext cx="977900" cy="654050"/>
+          </a:xfrm>
+          <a:prstGeom prst="rect">
+            <a:avLst/>
+          </a:prstGeom>
+          <a:noFill/>
+        </p:spPr>
+        <p:style>
+          <a:lnRef idx="2">
+            <a:schemeClr val="accent1">
+              <a:shade val="15000"/>
+            </a:schemeClr>
+          </a:lnRef>
+          <a:fillRef idx="1">
+            <a:schemeClr val="accent1"/>
+          </a:fillRef>
+          <a:effectRef idx="0">
+            <a:schemeClr val="accent1"/>
+          </a:effectRef>
+          <a:fontRef idx="minor">
+            <a:schemeClr val="lt1"/>
+          </a:fontRef>
+        </p:style>
+        <p:txBody>
+          <a:bodyPr rtlCol="0" anchor="ctr"/>
+          <a:lstStyle/>
+          <a:p>
+            <a:pPr algn="ctr"/>
+            <a:r>
+              <a:rPr lang="vi-VN" sz="1400" dirty="0">
+                <a:solidFill>
+                  <a:schemeClr val="tx1"/>
+                </a:solidFill>
+              </a:rPr>
+              <a:t>+5V_</a:t>
+            </a:r>
+            <a:r>
+              <a:rPr lang="en-US" sz="1400" dirty="0">
+                <a:solidFill>
+                  <a:schemeClr val="tx1"/>
+                </a:solidFill>
+              </a:rPr>
+              <a:t>Ana</a:t>
+            </a:r>
+            <a:endParaRPr lang="vi-VN" sz="1400" dirty="0">
+              <a:solidFill>
+                <a:schemeClr val="tx1"/>
+              </a:solidFill>
+            </a:endParaRPr>
+          </a:p>
+        </p:txBody>
+      </p:sp>
+      <p:cxnSp>
+        <p:nvCxnSpPr>
+          <p:cNvPr id="9" name="Connector: Elbow 8">
+            <a:extLst>
+              <a:ext uri="{FF2B5EF4-FFF2-40B4-BE49-F238E27FC236}">
+                <a16:creationId xmlns:a16="http://schemas.microsoft.com/office/drawing/2014/main" id="{8AAC0FA6-2A40-E173-AD94-4CFFEEBFB994}"/>
+              </a:ext>
+            </a:extLst>
+          </p:cNvPr>
+          <p:cNvCxnSpPr>
+            <a:stCxn id="4" idx="2"/>
+            <a:endCxn id="8" idx="1"/>
+          </p:cNvCxnSpPr>
+          <p:nvPr/>
+        </p:nvCxnSpPr>
+        <p:spPr>
+          <a:xfrm rot="16200000" flipH="1">
+            <a:off x="523875" y="3660774"/>
+            <a:ext cx="3270250" cy="1739901"/>
+          </a:xfrm>
+          <a:prstGeom prst="bentConnector2">
+            <a:avLst/>
+          </a:prstGeom>
+          <a:ln>
+            <a:tailEnd type="triangle"/>
+          </a:ln>
+        </p:spPr>
+        <p:style>
+          <a:lnRef idx="2">
+            <a:schemeClr val="accent1"/>
+          </a:lnRef>
+          <a:fillRef idx="0">
+            <a:schemeClr val="accent1"/>
+          </a:fillRef>
+          <a:effectRef idx="1">
+            <a:schemeClr val="accent1"/>
+          </a:effectRef>
+          <a:fontRef idx="minor">
+            <a:schemeClr val="tx1"/>
+          </a:fontRef>
+        </p:style>
+      </p:cxnSp>
+      <p:sp>
+        <p:nvSpPr>
+          <p:cNvPr id="10" name="TextBox 9">
+            <a:extLst>
+              <a:ext uri="{FF2B5EF4-FFF2-40B4-BE49-F238E27FC236}">
+                <a16:creationId xmlns:a16="http://schemas.microsoft.com/office/drawing/2014/main" id="{84DB196C-47AA-6B83-3BAB-EE8FC2EFFFD0}"/>
+              </a:ext>
+            </a:extLst>
+          </p:cNvPr>
+          <p:cNvSpPr txBox="1"/>
+          <p:nvPr/>
+        </p:nvSpPr>
+        <p:spPr>
+          <a:xfrm>
+            <a:off x="1854200" y="5913864"/>
+            <a:ext cx="1060450" cy="276999"/>
+          </a:xfrm>
+          <a:prstGeom prst="rect">
+            <a:avLst/>
+          </a:prstGeom>
+          <a:noFill/>
+        </p:spPr>
+        <p:txBody>
+          <a:bodyPr wrap="square" rtlCol="0">
+            <a:spAutoFit/>
+          </a:bodyPr>
+          <a:lstStyle/>
+          <a:p>
+            <a:r>
+              <a:rPr lang="en-US" sz="1200" dirty="0">
+                <a:solidFill>
+                  <a:srgbClr val="FF0000"/>
+                </a:solidFill>
+              </a:rPr>
+              <a:t>ADP7142-5.0</a:t>
+            </a:r>
+          </a:p>
+        </p:txBody>
+      </p:sp>
+      <p:sp>
+        <p:nvSpPr>
+          <p:cNvPr id="11" name="Rectangle 10">
+            <a:extLst>
+              <a:ext uri="{FF2B5EF4-FFF2-40B4-BE49-F238E27FC236}">
+                <a16:creationId xmlns:a16="http://schemas.microsoft.com/office/drawing/2014/main" id="{0C7BC14C-3D47-1942-B5BC-D68F57FE2A58}"/>
+              </a:ext>
+            </a:extLst>
+          </p:cNvPr>
+          <p:cNvSpPr/>
+          <p:nvPr/>
+        </p:nvSpPr>
+        <p:spPr>
+          <a:xfrm>
+            <a:off x="5391150" y="2241550"/>
+            <a:ext cx="1866900" cy="654050"/>
+          </a:xfrm>
+          <a:prstGeom prst="rect">
+            <a:avLst/>
+          </a:prstGeom>
+          <a:noFill/>
+        </p:spPr>
+        <p:style>
+          <a:lnRef idx="2">
+            <a:schemeClr val="accent1">
+              <a:shade val="15000"/>
+            </a:schemeClr>
+          </a:lnRef>
+          <a:fillRef idx="1">
+            <a:schemeClr val="accent1"/>
+          </a:fillRef>
+          <a:effectRef idx="0">
+            <a:schemeClr val="accent1"/>
+          </a:effectRef>
+          <a:fontRef idx="minor">
+            <a:schemeClr val="lt1"/>
+          </a:fontRef>
+        </p:style>
+        <p:txBody>
+          <a:bodyPr rtlCol="0" anchor="ctr"/>
+          <a:lstStyle/>
+          <a:p>
+            <a:pPr algn="ctr"/>
+            <a:r>
+              <a:rPr lang="en-US" sz="1400" dirty="0">
+                <a:solidFill>
+                  <a:schemeClr val="tx1"/>
+                </a:solidFill>
+              </a:rPr>
+              <a:t>3V3_CLK</a:t>
+            </a:r>
+            <a:br>
+              <a:rPr lang="en-US" sz="1400" dirty="0">
+                <a:solidFill>
+                  <a:schemeClr val="tx1"/>
+                </a:solidFill>
+              </a:rPr>
+            </a:br>
+            <a:r>
+              <a:rPr lang="en-US" sz="1400" dirty="0">
+                <a:solidFill>
+                  <a:schemeClr val="tx1"/>
+                </a:solidFill>
+              </a:rPr>
+              <a:t>and DVDD of AD9834</a:t>
+            </a:r>
+            <a:endParaRPr lang="vi-VN" sz="1400" dirty="0">
+              <a:solidFill>
+                <a:schemeClr val="tx1"/>
+              </a:solidFill>
+            </a:endParaRPr>
+          </a:p>
+        </p:txBody>
+      </p:sp>
+      <p:cxnSp>
+        <p:nvCxnSpPr>
+          <p:cNvPr id="12" name="Straight Arrow Connector 11">
+            <a:extLst>
+              <a:ext uri="{FF2B5EF4-FFF2-40B4-BE49-F238E27FC236}">
+                <a16:creationId xmlns:a16="http://schemas.microsoft.com/office/drawing/2014/main" id="{080C47E5-9585-BAB8-ECEA-A244361D5E49}"/>
+              </a:ext>
+            </a:extLst>
+          </p:cNvPr>
+          <p:cNvCxnSpPr>
+            <a:cxnSpLocks/>
+            <a:stCxn id="5" idx="3"/>
+            <a:endCxn id="11" idx="1"/>
+          </p:cNvCxnSpPr>
+          <p:nvPr/>
+        </p:nvCxnSpPr>
+        <p:spPr>
+          <a:xfrm>
+            <a:off x="4006850" y="2568575"/>
+            <a:ext cx="1384300" cy="0"/>
+          </a:xfrm>
+          <a:prstGeom prst="straightConnector1">
+            <a:avLst/>
+          </a:prstGeom>
+          <a:ln>
+            <a:tailEnd type="triangle"/>
+          </a:ln>
+        </p:spPr>
+        <p:style>
+          <a:lnRef idx="2">
+            <a:schemeClr val="accent1"/>
+          </a:lnRef>
+          <a:fillRef idx="0">
+            <a:schemeClr val="accent1"/>
+          </a:fillRef>
+          <a:effectRef idx="1">
+            <a:schemeClr val="accent1"/>
+          </a:effectRef>
+          <a:fontRef idx="minor">
+            <a:schemeClr val="tx1"/>
+          </a:fontRef>
+        </p:style>
+      </p:cxnSp>
+      <p:sp>
+        <p:nvSpPr>
+          <p:cNvPr id="13" name="TextBox 12">
+            <a:extLst>
+              <a:ext uri="{FF2B5EF4-FFF2-40B4-BE49-F238E27FC236}">
+                <a16:creationId xmlns:a16="http://schemas.microsoft.com/office/drawing/2014/main" id="{ED4CD196-0ECB-6ED3-1483-02955717E83D}"/>
+              </a:ext>
+            </a:extLst>
+          </p:cNvPr>
+          <p:cNvSpPr txBox="1"/>
+          <p:nvPr/>
+        </p:nvSpPr>
+        <p:spPr>
+          <a:xfrm>
+            <a:off x="4171950" y="2340059"/>
+            <a:ext cx="1054100" cy="276999"/>
+          </a:xfrm>
+          <a:prstGeom prst="rect">
+            <a:avLst/>
+          </a:prstGeom>
+          <a:noFill/>
+        </p:spPr>
+        <p:txBody>
+          <a:bodyPr wrap="square" rtlCol="0">
+            <a:spAutoFit/>
+          </a:bodyPr>
+          <a:lstStyle/>
+          <a:p>
+            <a:r>
+              <a:rPr lang="en-US" sz="1200" dirty="0">
+                <a:solidFill>
+                  <a:srgbClr val="FF0000"/>
+                </a:solidFill>
+              </a:rPr>
+              <a:t>ADP7118-3.3</a:t>
+            </a:r>
+          </a:p>
+        </p:txBody>
+      </p:sp>
+      <p:cxnSp>
+        <p:nvCxnSpPr>
+          <p:cNvPr id="14" name="Connector: Elbow 13">
+            <a:extLst>
+              <a:ext uri="{FF2B5EF4-FFF2-40B4-BE49-F238E27FC236}">
+                <a16:creationId xmlns:a16="http://schemas.microsoft.com/office/drawing/2014/main" id="{301B36B3-E979-92ED-BCC9-F8D2E05B41B6}"/>
+              </a:ext>
+            </a:extLst>
+          </p:cNvPr>
+          <p:cNvCxnSpPr>
+            <a:cxnSpLocks/>
+            <a:stCxn id="5" idx="2"/>
+            <a:endCxn id="15" idx="1"/>
+          </p:cNvCxnSpPr>
+          <p:nvPr/>
+        </p:nvCxnSpPr>
+        <p:spPr>
+          <a:xfrm rot="16200000" flipH="1">
+            <a:off x="4117975" y="2295525"/>
+            <a:ext cx="673100" cy="1873250"/>
+          </a:xfrm>
+          <a:prstGeom prst="bentConnector2">
+            <a:avLst/>
+          </a:prstGeom>
+          <a:ln>
+            <a:tailEnd type="triangle"/>
+          </a:ln>
+        </p:spPr>
+        <p:style>
+          <a:lnRef idx="2">
+            <a:schemeClr val="accent1"/>
+          </a:lnRef>
+          <a:fillRef idx="0">
+            <a:schemeClr val="accent1"/>
+          </a:fillRef>
+          <a:effectRef idx="1">
+            <a:schemeClr val="accent1"/>
+          </a:effectRef>
+          <a:fontRef idx="minor">
+            <a:schemeClr val="tx1"/>
+          </a:fontRef>
+        </p:style>
+      </p:cxnSp>
+      <p:sp>
+        <p:nvSpPr>
+          <p:cNvPr id="15" name="Rectangle 14">
+            <a:extLst>
+              <a:ext uri="{FF2B5EF4-FFF2-40B4-BE49-F238E27FC236}">
+                <a16:creationId xmlns:a16="http://schemas.microsoft.com/office/drawing/2014/main" id="{5E4681BF-9ACB-3D8E-EAFE-F0B164BAEAB6}"/>
+              </a:ext>
+            </a:extLst>
+          </p:cNvPr>
+          <p:cNvSpPr/>
+          <p:nvPr/>
+        </p:nvSpPr>
+        <p:spPr>
+          <a:xfrm>
+            <a:off x="5391150" y="3241675"/>
+            <a:ext cx="1866900" cy="654050"/>
+          </a:xfrm>
+          <a:prstGeom prst="rect">
+            <a:avLst/>
+          </a:prstGeom>
+          <a:noFill/>
+        </p:spPr>
+        <p:style>
+          <a:lnRef idx="2">
+            <a:schemeClr val="accent1">
+              <a:shade val="15000"/>
+            </a:schemeClr>
+          </a:lnRef>
+          <a:fillRef idx="1">
+            <a:schemeClr val="accent1"/>
+          </a:fillRef>
+          <a:effectRef idx="0">
+            <a:schemeClr val="accent1"/>
+          </a:effectRef>
+          <a:fontRef idx="minor">
+            <a:schemeClr val="lt1"/>
+          </a:fontRef>
+        </p:style>
+        <p:txBody>
+          <a:bodyPr rtlCol="0" anchor="ctr"/>
+          <a:lstStyle/>
+          <a:p>
+            <a:pPr algn="ctr"/>
+            <a:r>
+              <a:rPr lang="vi-VN" sz="1400" dirty="0">
+                <a:solidFill>
+                  <a:schemeClr val="tx1"/>
+                </a:solidFill>
+              </a:rPr>
+              <a:t>MCU power</a:t>
+            </a:r>
+          </a:p>
+        </p:txBody>
+      </p:sp>
+      <p:sp>
+        <p:nvSpPr>
+          <p:cNvPr id="16" name="TextBox 15">
+            <a:extLst>
+              <a:ext uri="{FF2B5EF4-FFF2-40B4-BE49-F238E27FC236}">
+                <a16:creationId xmlns:a16="http://schemas.microsoft.com/office/drawing/2014/main" id="{C3EFF121-554F-FA1B-6B4D-3795A7250849}"/>
+              </a:ext>
+            </a:extLst>
+          </p:cNvPr>
+          <p:cNvSpPr txBox="1"/>
+          <p:nvPr/>
+        </p:nvSpPr>
+        <p:spPr>
+          <a:xfrm>
+            <a:off x="4171950" y="3305259"/>
+            <a:ext cx="1054100" cy="276999"/>
+          </a:xfrm>
+          <a:prstGeom prst="rect">
+            <a:avLst/>
+          </a:prstGeom>
+          <a:noFill/>
+        </p:spPr>
+        <p:txBody>
+          <a:bodyPr wrap="square" rtlCol="0">
+            <a:spAutoFit/>
+          </a:bodyPr>
+          <a:lstStyle/>
+          <a:p>
+            <a:r>
+              <a:rPr lang="en-US" sz="1200" dirty="0">
+                <a:solidFill>
+                  <a:srgbClr val="FF0000"/>
+                </a:solidFill>
+              </a:rPr>
+              <a:t>TPS7A2033</a:t>
+            </a:r>
+          </a:p>
+        </p:txBody>
+      </p:sp>
+      <p:sp>
+        <p:nvSpPr>
+          <p:cNvPr id="31" name="Rectangle 30">
+            <a:extLst>
+              <a:ext uri="{FF2B5EF4-FFF2-40B4-BE49-F238E27FC236}">
+                <a16:creationId xmlns:a16="http://schemas.microsoft.com/office/drawing/2014/main" id="{02AF7FB6-B41B-6F26-1A45-B71023847DAB}"/>
+              </a:ext>
+            </a:extLst>
+          </p:cNvPr>
+          <p:cNvSpPr/>
+          <p:nvPr/>
+        </p:nvSpPr>
+        <p:spPr>
+          <a:xfrm>
+            <a:off x="5391150" y="4241800"/>
+            <a:ext cx="1866900" cy="654050"/>
+          </a:xfrm>
+          <a:prstGeom prst="rect">
+            <a:avLst/>
+          </a:prstGeom>
+          <a:noFill/>
+        </p:spPr>
+        <p:style>
+          <a:lnRef idx="2">
+            <a:schemeClr val="accent1">
+              <a:shade val="15000"/>
+            </a:schemeClr>
+          </a:lnRef>
+          <a:fillRef idx="1">
+            <a:schemeClr val="accent1"/>
+          </a:fillRef>
+          <a:effectRef idx="0">
+            <a:schemeClr val="accent1"/>
+          </a:effectRef>
+          <a:fontRef idx="minor">
+            <a:schemeClr val="lt1"/>
+          </a:fontRef>
+        </p:style>
+        <p:txBody>
+          <a:bodyPr rtlCol="0" anchor="ctr"/>
+          <a:lstStyle/>
+          <a:p>
+            <a:pPr algn="ctr"/>
+            <a:r>
+              <a:rPr lang="vi-VN" sz="1400" dirty="0">
+                <a:solidFill>
+                  <a:schemeClr val="tx1"/>
+                </a:solidFill>
+              </a:rPr>
+              <a:t>-5V Raw</a:t>
+            </a:r>
+          </a:p>
+        </p:txBody>
+      </p:sp>
+      <p:cxnSp>
+        <p:nvCxnSpPr>
+          <p:cNvPr id="33" name="Connector: Elbow 32">
+            <a:extLst>
+              <a:ext uri="{FF2B5EF4-FFF2-40B4-BE49-F238E27FC236}">
+                <a16:creationId xmlns:a16="http://schemas.microsoft.com/office/drawing/2014/main" id="{177DA1C4-08E5-AC62-F6AB-1D26E243950E}"/>
+              </a:ext>
+            </a:extLst>
+          </p:cNvPr>
+          <p:cNvCxnSpPr>
+            <a:stCxn id="5" idx="2"/>
+            <a:endCxn id="31" idx="1"/>
+          </p:cNvCxnSpPr>
+          <p:nvPr/>
+        </p:nvCxnSpPr>
+        <p:spPr>
+          <a:xfrm rot="16200000" flipH="1">
+            <a:off x="3617913" y="2795587"/>
+            <a:ext cx="1673225" cy="1873250"/>
+          </a:xfrm>
+          <a:prstGeom prst="bentConnector2">
+            <a:avLst/>
+          </a:prstGeom>
+          <a:ln>
+            <a:tailEnd type="triangle"/>
+          </a:ln>
+        </p:spPr>
+        <p:style>
+          <a:lnRef idx="2">
+            <a:schemeClr val="accent1"/>
+          </a:lnRef>
+          <a:fillRef idx="0">
+            <a:schemeClr val="accent1"/>
+          </a:fillRef>
+          <a:effectRef idx="1">
+            <a:schemeClr val="accent1"/>
+          </a:effectRef>
+          <a:fontRef idx="minor">
+            <a:schemeClr val="tx1"/>
+          </a:fontRef>
+        </p:style>
+      </p:cxnSp>
+      <p:sp>
+        <p:nvSpPr>
+          <p:cNvPr id="34" name="TextBox 33">
+            <a:extLst>
+              <a:ext uri="{FF2B5EF4-FFF2-40B4-BE49-F238E27FC236}">
+                <a16:creationId xmlns:a16="http://schemas.microsoft.com/office/drawing/2014/main" id="{4F8C862B-3405-EDAD-86DF-A60992373E35}"/>
+              </a:ext>
+            </a:extLst>
+          </p:cNvPr>
+          <p:cNvSpPr txBox="1"/>
+          <p:nvPr/>
+        </p:nvSpPr>
+        <p:spPr>
+          <a:xfrm>
+            <a:off x="4292600" y="4316838"/>
+            <a:ext cx="812800" cy="276999"/>
+          </a:xfrm>
+          <a:prstGeom prst="rect">
+            <a:avLst/>
+          </a:prstGeom>
+          <a:noFill/>
+        </p:spPr>
+        <p:txBody>
+          <a:bodyPr wrap="square" rtlCol="0">
+            <a:spAutoFit/>
+          </a:bodyPr>
+          <a:lstStyle/>
+          <a:p>
+            <a:r>
+              <a:rPr lang="en-US" sz="1200" dirty="0">
+                <a:solidFill>
+                  <a:srgbClr val="FF0000"/>
+                </a:solidFill>
+              </a:rPr>
+              <a:t>ADP5070 </a:t>
+            </a:r>
+          </a:p>
+        </p:txBody>
+      </p:sp>
+      <p:sp>
+        <p:nvSpPr>
+          <p:cNvPr id="36" name="Rectangle 35">
+            <a:extLst>
+              <a:ext uri="{FF2B5EF4-FFF2-40B4-BE49-F238E27FC236}">
+                <a16:creationId xmlns:a16="http://schemas.microsoft.com/office/drawing/2014/main" id="{E9795A88-C21E-4A1B-CDC1-6650ACA9A5E6}"/>
+              </a:ext>
+            </a:extLst>
+          </p:cNvPr>
+          <p:cNvSpPr/>
+          <p:nvPr/>
+        </p:nvSpPr>
+        <p:spPr>
+          <a:xfrm>
+            <a:off x="8686799" y="4241800"/>
+            <a:ext cx="1866900" cy="654050"/>
+          </a:xfrm>
+          <a:prstGeom prst="rect">
+            <a:avLst/>
+          </a:prstGeom>
+          <a:noFill/>
+        </p:spPr>
+        <p:style>
+          <a:lnRef idx="2">
+            <a:schemeClr val="accent1">
+              <a:shade val="15000"/>
+            </a:schemeClr>
+          </a:lnRef>
+          <a:fillRef idx="1">
+            <a:schemeClr val="accent1"/>
+          </a:fillRef>
+          <a:effectRef idx="0">
+            <a:schemeClr val="accent1"/>
+          </a:effectRef>
+          <a:fontRef idx="minor">
+            <a:schemeClr val="lt1"/>
+          </a:fontRef>
+        </p:style>
+        <p:txBody>
+          <a:bodyPr rtlCol="0" anchor="ctr"/>
+          <a:lstStyle/>
+          <a:p>
+            <a:pPr algn="ctr"/>
+            <a:r>
+              <a:rPr lang="vi-VN" sz="1400" dirty="0">
+                <a:solidFill>
+                  <a:schemeClr val="tx1"/>
+                </a:solidFill>
+              </a:rPr>
+              <a:t>-5V Ana</a:t>
+            </a:r>
+          </a:p>
+        </p:txBody>
+      </p:sp>
+      <p:cxnSp>
+        <p:nvCxnSpPr>
+          <p:cNvPr id="38" name="Straight Arrow Connector 37">
+            <a:extLst>
+              <a:ext uri="{FF2B5EF4-FFF2-40B4-BE49-F238E27FC236}">
+                <a16:creationId xmlns:a16="http://schemas.microsoft.com/office/drawing/2014/main" id="{582A7728-C182-301B-F51A-355AE4B3F747}"/>
+              </a:ext>
+            </a:extLst>
+          </p:cNvPr>
+          <p:cNvCxnSpPr>
+            <a:stCxn id="31" idx="3"/>
+            <a:endCxn id="36" idx="1"/>
+          </p:cNvCxnSpPr>
+          <p:nvPr/>
+        </p:nvCxnSpPr>
+        <p:spPr>
+          <a:xfrm>
+            <a:off x="7258050" y="4568825"/>
+            <a:ext cx="1428749" cy="0"/>
+          </a:xfrm>
+          <a:prstGeom prst="straightConnector1">
+            <a:avLst/>
+          </a:prstGeom>
+          <a:ln>
+            <a:tailEnd type="triangle"/>
+          </a:ln>
+        </p:spPr>
+        <p:style>
+          <a:lnRef idx="2">
+            <a:schemeClr val="accent1"/>
+          </a:lnRef>
+          <a:fillRef idx="0">
+            <a:schemeClr val="accent1"/>
+          </a:fillRef>
+          <a:effectRef idx="1">
+            <a:schemeClr val="accent1"/>
+          </a:effectRef>
+          <a:fontRef idx="minor">
+            <a:schemeClr val="tx1"/>
+          </a:fontRef>
+        </p:style>
+      </p:cxnSp>
+      <p:sp>
+        <p:nvSpPr>
+          <p:cNvPr id="40" name="TextBox 39">
+            <a:extLst>
+              <a:ext uri="{FF2B5EF4-FFF2-40B4-BE49-F238E27FC236}">
+                <a16:creationId xmlns:a16="http://schemas.microsoft.com/office/drawing/2014/main" id="{B21D7E8A-BCBD-759B-ADCA-D3B04BEAAF13}"/>
+              </a:ext>
+            </a:extLst>
+          </p:cNvPr>
+          <p:cNvSpPr txBox="1"/>
+          <p:nvPr/>
+        </p:nvSpPr>
+        <p:spPr>
+          <a:xfrm>
+            <a:off x="7566024" y="4291826"/>
+            <a:ext cx="812800" cy="276999"/>
+          </a:xfrm>
+          <a:prstGeom prst="rect">
+            <a:avLst/>
+          </a:prstGeom>
+          <a:noFill/>
+        </p:spPr>
+        <p:txBody>
+          <a:bodyPr wrap="square" rtlCol="0">
+            <a:spAutoFit/>
+          </a:bodyPr>
+          <a:lstStyle/>
+          <a:p>
+            <a:r>
+              <a:rPr lang="en-US" sz="1200" dirty="0">
+                <a:solidFill>
+                  <a:srgbClr val="FF0000"/>
+                </a:solidFill>
+              </a:rPr>
+              <a:t>ADP7182 </a:t>
+            </a:r>
+          </a:p>
+        </p:txBody>
+      </p:sp>
+    </p:spTree>
+    <p:extLst>
+      <p:ext uri="{BB962C8B-B14F-4D97-AF65-F5344CB8AC3E}">
+        <p14:creationId xmlns:p14="http://schemas.microsoft.com/office/powerpoint/2010/main" val="3075629485"/>
+      </p:ext>
+    </p:extLst>
+  </p:cSld>
+  <p:clrMapOvr>
+    <a:masterClrMapping/>
+  </p:clrMapOvr>
+</p:sld>
+</file>
+
 <file path=ppt/theme/theme1.xml><?xml version="1.0" encoding="utf-8"?>
 <a:theme xmlns:a="http://schemas.openxmlformats.org/drawingml/2006/main" name="Office Theme">
   <a:themeElements>

</xml_diff>